<commit_message>
IBS script set up
</commit_message>
<xml_diff>
--- a/Summary/figures.pptx
+++ b/Summary/figures.pptx
@@ -149,7 +149,7 @@
 <file path=ppt/revisionInfo.xml><?xml version="1.0" encoding="utf-8"?>
 <p1510:revInfo xmlns:a="http://schemas.openxmlformats.org/drawingml/2006/main" xmlns:r="http://schemas.openxmlformats.org/officeDocument/2006/relationships" xmlns:p1510="http://schemas.microsoft.com/office/powerpoint/2015/10/main">
   <p1510:revLst>
-    <p1510:client id="{AF93BDFE-E7B1-48C6-AB80-E9611D4B0775}" v="4" dt="2026-03-25T22:45:32.638"/>
+    <p1510:client id="{AF93BDFE-E7B1-48C6-AB80-E9611D4B0775}" v="8" dt="2026-04-07T18:52:54.548"/>
   </p1510:revLst>
 </p1510:revInfo>
 </file>
@@ -159,7 +159,7 @@
   <pc:docChgLst>
     <pc:chgData name="Jonathan Mah" userId="5261b2f2f3e51194" providerId="LiveId" clId="{DB9BCF8B-E91B-491C-8171-92D39BBC1534}"/>
     <pc:docChg chg="undo redo custSel addSld delSld modSld sldOrd modSection">
-      <pc:chgData name="Jonathan Mah" userId="5261b2f2f3e51194" providerId="LiveId" clId="{DB9BCF8B-E91B-491C-8171-92D39BBC1534}" dt="2026-04-06T19:01:41.481" v="1469"/>
+      <pc:chgData name="Jonathan Mah" userId="5261b2f2f3e51194" providerId="LiveId" clId="{DB9BCF8B-E91B-491C-8171-92D39BBC1534}" dt="2026-04-07T18:53:03.011" v="1522" actId="1076"/>
       <pc:docMkLst>
         <pc:docMk/>
       </pc:docMkLst>
@@ -176,6 +176,189 @@
           <pc:docMk/>
           <pc:sldMk cId="2126933953" sldId="423"/>
         </pc:sldMkLst>
+      </pc:sldChg>
+      <pc:sldChg chg="addSp delSp modSp mod">
+        <pc:chgData name="Jonathan Mah" userId="5261b2f2f3e51194" providerId="LiveId" clId="{DB9BCF8B-E91B-491C-8171-92D39BBC1534}" dt="2026-04-07T18:53:03.011" v="1522" actId="1076"/>
+        <pc:sldMkLst>
+          <pc:docMk/>
+          <pc:sldMk cId="1601061642" sldId="512"/>
+        </pc:sldMkLst>
+        <pc:spChg chg="add mod">
+          <ac:chgData name="Jonathan Mah" userId="5261b2f2f3e51194" providerId="LiveId" clId="{DB9BCF8B-E91B-491C-8171-92D39BBC1534}" dt="2026-04-07T18:52:33.412" v="1517" actId="1076"/>
+          <ac:spMkLst>
+            <pc:docMk/>
+            <pc:sldMk cId="1601061642" sldId="512"/>
+            <ac:spMk id="18" creationId="{E693494A-1F6E-3828-5FF9-CDAB056D0BCE}"/>
+          </ac:spMkLst>
+        </pc:spChg>
+        <pc:spChg chg="add mod">
+          <ac:chgData name="Jonathan Mah" userId="5261b2f2f3e51194" providerId="LiveId" clId="{DB9BCF8B-E91B-491C-8171-92D39BBC1534}" dt="2026-04-07T18:52:33.412" v="1517" actId="1076"/>
+          <ac:spMkLst>
+            <pc:docMk/>
+            <pc:sldMk cId="1601061642" sldId="512"/>
+            <ac:spMk id="19" creationId="{C1E6029E-39DA-FD90-8B4A-32E98571088F}"/>
+          </ac:spMkLst>
+        </pc:spChg>
+        <pc:spChg chg="add mod">
+          <ac:chgData name="Jonathan Mah" userId="5261b2f2f3e51194" providerId="LiveId" clId="{DB9BCF8B-E91B-491C-8171-92D39BBC1534}" dt="2026-04-07T18:52:33.412" v="1517" actId="1076"/>
+          <ac:spMkLst>
+            <pc:docMk/>
+            <pc:sldMk cId="1601061642" sldId="512"/>
+            <ac:spMk id="22" creationId="{1CE5FA1F-948A-538B-E275-31FE8E471619}"/>
+          </ac:spMkLst>
+        </pc:spChg>
+        <pc:spChg chg="add mod">
+          <ac:chgData name="Jonathan Mah" userId="5261b2f2f3e51194" providerId="LiveId" clId="{DB9BCF8B-E91B-491C-8171-92D39BBC1534}" dt="2026-04-07T18:52:33.412" v="1517" actId="1076"/>
+          <ac:spMkLst>
+            <pc:docMk/>
+            <pc:sldMk cId="1601061642" sldId="512"/>
+            <ac:spMk id="23" creationId="{FE72382F-F6F9-66C7-4183-4E055D409F7D}"/>
+          </ac:spMkLst>
+        </pc:spChg>
+        <pc:spChg chg="mod">
+          <ac:chgData name="Jonathan Mah" userId="5261b2f2f3e51194" providerId="LiveId" clId="{DB9BCF8B-E91B-491C-8171-92D39BBC1534}" dt="2026-04-07T18:52:40.930" v="1518" actId="1076"/>
+          <ac:spMkLst>
+            <pc:docMk/>
+            <pc:sldMk cId="1601061642" sldId="512"/>
+            <ac:spMk id="24" creationId="{ACB078C8-4156-AC31-CFB4-4A88C1B62115}"/>
+          </ac:spMkLst>
+        </pc:spChg>
+        <pc:spChg chg="add mod">
+          <ac:chgData name="Jonathan Mah" userId="5261b2f2f3e51194" providerId="LiveId" clId="{DB9BCF8B-E91B-491C-8171-92D39BBC1534}" dt="2026-04-07T18:52:33.412" v="1517" actId="1076"/>
+          <ac:spMkLst>
+            <pc:docMk/>
+            <pc:sldMk cId="1601061642" sldId="512"/>
+            <ac:spMk id="38" creationId="{FC0509F7-8873-EC72-329F-1640ED6E36B3}"/>
+          </ac:spMkLst>
+        </pc:spChg>
+        <pc:spChg chg="add mod">
+          <ac:chgData name="Jonathan Mah" userId="5261b2f2f3e51194" providerId="LiveId" clId="{DB9BCF8B-E91B-491C-8171-92D39BBC1534}" dt="2026-04-07T18:52:33.412" v="1517" actId="1076"/>
+          <ac:spMkLst>
+            <pc:docMk/>
+            <pc:sldMk cId="1601061642" sldId="512"/>
+            <ac:spMk id="39" creationId="{5680E036-C301-C623-414E-BC2D5E341D9A}"/>
+          </ac:spMkLst>
+        </pc:spChg>
+        <pc:spChg chg="add mod">
+          <ac:chgData name="Jonathan Mah" userId="5261b2f2f3e51194" providerId="LiveId" clId="{DB9BCF8B-E91B-491C-8171-92D39BBC1534}" dt="2026-04-07T18:52:52.005" v="1520" actId="1076"/>
+          <ac:spMkLst>
+            <pc:docMk/>
+            <pc:sldMk cId="1601061642" sldId="512"/>
+            <ac:spMk id="40" creationId="{7688E15F-1386-C937-0163-2EC5DDC4ACE1}"/>
+          </ac:spMkLst>
+        </pc:spChg>
+        <pc:spChg chg="add mod">
+          <ac:chgData name="Jonathan Mah" userId="5261b2f2f3e51194" providerId="LiveId" clId="{DB9BCF8B-E91B-491C-8171-92D39BBC1534}" dt="2026-04-07T18:52:52.005" v="1520" actId="1076"/>
+          <ac:spMkLst>
+            <pc:docMk/>
+            <pc:sldMk cId="1601061642" sldId="512"/>
+            <ac:spMk id="41" creationId="{B641507C-62A6-FF4F-D8BC-CDF153439BD5}"/>
+          </ac:spMkLst>
+        </pc:spChg>
+        <pc:spChg chg="add mod">
+          <ac:chgData name="Jonathan Mah" userId="5261b2f2f3e51194" providerId="LiveId" clId="{DB9BCF8B-E91B-491C-8171-92D39BBC1534}" dt="2026-04-07T18:52:52.005" v="1520" actId="1076"/>
+          <ac:spMkLst>
+            <pc:docMk/>
+            <pc:sldMk cId="1601061642" sldId="512"/>
+            <ac:spMk id="42" creationId="{DE6853C4-E8CA-CF2A-8099-234DC2B4E289}"/>
+          </ac:spMkLst>
+        </pc:spChg>
+        <pc:spChg chg="add mod">
+          <ac:chgData name="Jonathan Mah" userId="5261b2f2f3e51194" providerId="LiveId" clId="{DB9BCF8B-E91B-491C-8171-92D39BBC1534}" dt="2026-04-07T18:52:52.005" v="1520" actId="1076"/>
+          <ac:spMkLst>
+            <pc:docMk/>
+            <pc:sldMk cId="1601061642" sldId="512"/>
+            <ac:spMk id="43" creationId="{305571C5-AE62-5FEB-178F-92AF31427263}"/>
+          </ac:spMkLst>
+        </pc:spChg>
+        <pc:spChg chg="add mod">
+          <ac:chgData name="Jonathan Mah" userId="5261b2f2f3e51194" providerId="LiveId" clId="{DB9BCF8B-E91B-491C-8171-92D39BBC1534}" dt="2026-04-07T18:52:52.005" v="1520" actId="1076"/>
+          <ac:spMkLst>
+            <pc:docMk/>
+            <pc:sldMk cId="1601061642" sldId="512"/>
+            <ac:spMk id="44" creationId="{A5BD21AD-9160-37C5-E402-1912AF878518}"/>
+          </ac:spMkLst>
+        </pc:spChg>
+        <pc:spChg chg="add mod">
+          <ac:chgData name="Jonathan Mah" userId="5261b2f2f3e51194" providerId="LiveId" clId="{DB9BCF8B-E91B-491C-8171-92D39BBC1534}" dt="2026-04-07T18:52:52.005" v="1520" actId="1076"/>
+          <ac:spMkLst>
+            <pc:docMk/>
+            <pc:sldMk cId="1601061642" sldId="512"/>
+            <ac:spMk id="45" creationId="{871380D0-3166-4CAB-8D48-B8B10A1216F4}"/>
+          </ac:spMkLst>
+        </pc:spChg>
+        <pc:spChg chg="add mod">
+          <ac:chgData name="Jonathan Mah" userId="5261b2f2f3e51194" providerId="LiveId" clId="{DB9BCF8B-E91B-491C-8171-92D39BBC1534}" dt="2026-04-07T18:53:03.011" v="1522" actId="1076"/>
+          <ac:spMkLst>
+            <pc:docMk/>
+            <pc:sldMk cId="1601061642" sldId="512"/>
+            <ac:spMk id="46" creationId="{669993EF-587D-E4B8-4DCB-745E77C10007}"/>
+          </ac:spMkLst>
+        </pc:spChg>
+        <pc:spChg chg="add mod">
+          <ac:chgData name="Jonathan Mah" userId="5261b2f2f3e51194" providerId="LiveId" clId="{DB9BCF8B-E91B-491C-8171-92D39BBC1534}" dt="2026-04-07T18:53:03.011" v="1522" actId="1076"/>
+          <ac:spMkLst>
+            <pc:docMk/>
+            <pc:sldMk cId="1601061642" sldId="512"/>
+            <ac:spMk id="47" creationId="{4315D537-113D-8E6A-1582-C204AA39D1FF}"/>
+          </ac:spMkLst>
+        </pc:spChg>
+        <pc:spChg chg="add mod">
+          <ac:chgData name="Jonathan Mah" userId="5261b2f2f3e51194" providerId="LiveId" clId="{DB9BCF8B-E91B-491C-8171-92D39BBC1534}" dt="2026-04-07T18:53:03.011" v="1522" actId="1076"/>
+          <ac:spMkLst>
+            <pc:docMk/>
+            <pc:sldMk cId="1601061642" sldId="512"/>
+            <ac:spMk id="48" creationId="{963E9682-998A-6596-A3B2-CF7BDC9DF45C}"/>
+          </ac:spMkLst>
+        </pc:spChg>
+        <pc:spChg chg="add mod">
+          <ac:chgData name="Jonathan Mah" userId="5261b2f2f3e51194" providerId="LiveId" clId="{DB9BCF8B-E91B-491C-8171-92D39BBC1534}" dt="2026-04-07T18:53:03.011" v="1522" actId="1076"/>
+          <ac:spMkLst>
+            <pc:docMk/>
+            <pc:sldMk cId="1601061642" sldId="512"/>
+            <ac:spMk id="49" creationId="{BB2FCBC0-DF2A-1EB3-1EB7-9D014B509F6B}"/>
+          </ac:spMkLst>
+        </pc:spChg>
+        <pc:spChg chg="add mod">
+          <ac:chgData name="Jonathan Mah" userId="5261b2f2f3e51194" providerId="LiveId" clId="{DB9BCF8B-E91B-491C-8171-92D39BBC1534}" dt="2026-04-07T18:53:03.011" v="1522" actId="1076"/>
+          <ac:spMkLst>
+            <pc:docMk/>
+            <pc:sldMk cId="1601061642" sldId="512"/>
+            <ac:spMk id="50" creationId="{380B9967-3D2A-6290-9C24-45B1B3248F5A}"/>
+          </ac:spMkLst>
+        </pc:spChg>
+        <pc:spChg chg="add mod">
+          <ac:chgData name="Jonathan Mah" userId="5261b2f2f3e51194" providerId="LiveId" clId="{DB9BCF8B-E91B-491C-8171-92D39BBC1534}" dt="2026-04-07T18:53:03.011" v="1522" actId="1076"/>
+          <ac:spMkLst>
+            <pc:docMk/>
+            <pc:sldMk cId="1601061642" sldId="512"/>
+            <ac:spMk id="51" creationId="{9BBB25C2-AD51-EF46-0526-6F8284826624}"/>
+          </ac:spMkLst>
+        </pc:spChg>
+        <pc:picChg chg="del">
+          <ac:chgData name="Jonathan Mah" userId="5261b2f2f3e51194" providerId="LiveId" clId="{DB9BCF8B-E91B-491C-8171-92D39BBC1534}" dt="2026-04-07T18:50:16.367" v="1472" actId="478"/>
+          <ac:picMkLst>
+            <pc:docMk/>
+            <pc:sldMk cId="1601061642" sldId="512"/>
+            <ac:picMk id="20" creationId="{63E7276F-F01B-934A-CFDD-FB6D5F2EC7FE}"/>
+          </ac:picMkLst>
+        </pc:picChg>
+        <pc:picChg chg="del">
+          <ac:chgData name="Jonathan Mah" userId="5261b2f2f3e51194" providerId="LiveId" clId="{DB9BCF8B-E91B-491C-8171-92D39BBC1534}" dt="2026-04-07T18:50:15.402" v="1470" actId="478"/>
+          <ac:picMkLst>
+            <pc:docMk/>
+            <pc:sldMk cId="1601061642" sldId="512"/>
+            <ac:picMk id="27" creationId="{2D97DDCB-7229-9321-0F73-E66F51B159CC}"/>
+          </ac:picMkLst>
+        </pc:picChg>
+        <pc:picChg chg="del">
+          <ac:chgData name="Jonathan Mah" userId="5261b2f2f3e51194" providerId="LiveId" clId="{DB9BCF8B-E91B-491C-8171-92D39BBC1534}" dt="2026-04-07T18:50:15.709" v="1471" actId="478"/>
+          <ac:picMkLst>
+            <pc:docMk/>
+            <pc:sldMk cId="1601061642" sldId="512"/>
+            <ac:picMk id="28" creationId="{D84EF3F0-23DB-F3D5-FE38-1150762ADF3E}"/>
+          </ac:picMkLst>
+        </pc:picChg>
       </pc:sldChg>
       <pc:sldChg chg="del">
         <pc:chgData name="Jonathan Mah" userId="5261b2f2f3e51194" providerId="LiveId" clId="{DB9BCF8B-E91B-491C-8171-92D39BBC1534}" dt="2026-04-06T19:00:30.307" v="1466" actId="47"/>
@@ -562,7 +745,7 @@
           <a:p>
             <a:fld id="{224F4B04-6A50-4A51-B675-D86EC6563060}" type="datetimeFigureOut">
               <a:rPr lang="en-US" smtClean="0"/>
-              <a:t>4/6/2026</a:t>
+              <a:t>4/7/2026</a:t>
             </a:fld>
             <a:endParaRPr lang="en-US"/>
           </a:p>
@@ -960,7 +1143,7 @@
           <a:p>
             <a:fld id="{54E435BD-4569-4C00-96FD-DE6EEAA430DA}" type="datetimeFigureOut">
               <a:rPr lang="en-US" smtClean="0"/>
-              <a:t>4/6/2026</a:t>
+              <a:t>4/7/2026</a:t>
             </a:fld>
             <a:endParaRPr lang="en-US"/>
           </a:p>
@@ -1130,7 +1313,7 @@
           <a:p>
             <a:fld id="{54E435BD-4569-4C00-96FD-DE6EEAA430DA}" type="datetimeFigureOut">
               <a:rPr lang="en-US" smtClean="0"/>
-              <a:t>4/6/2026</a:t>
+              <a:t>4/7/2026</a:t>
             </a:fld>
             <a:endParaRPr lang="en-US"/>
           </a:p>
@@ -1310,7 +1493,7 @@
           <a:p>
             <a:fld id="{54E435BD-4569-4C00-96FD-DE6EEAA430DA}" type="datetimeFigureOut">
               <a:rPr lang="en-US" smtClean="0"/>
-              <a:t>4/6/2026</a:t>
+              <a:t>4/7/2026</a:t>
             </a:fld>
             <a:endParaRPr lang="en-US"/>
           </a:p>
@@ -1480,7 +1663,7 @@
           <a:p>
             <a:fld id="{54E435BD-4569-4C00-96FD-DE6EEAA430DA}" type="datetimeFigureOut">
               <a:rPr lang="en-US" smtClean="0"/>
-              <a:t>4/6/2026</a:t>
+              <a:t>4/7/2026</a:t>
             </a:fld>
             <a:endParaRPr lang="en-US"/>
           </a:p>
@@ -1724,7 +1907,7 @@
           <a:p>
             <a:fld id="{54E435BD-4569-4C00-96FD-DE6EEAA430DA}" type="datetimeFigureOut">
               <a:rPr lang="en-US" smtClean="0"/>
-              <a:t>4/6/2026</a:t>
+              <a:t>4/7/2026</a:t>
             </a:fld>
             <a:endParaRPr lang="en-US"/>
           </a:p>
@@ -1956,7 +2139,7 @@
           <a:p>
             <a:fld id="{54E435BD-4569-4C00-96FD-DE6EEAA430DA}" type="datetimeFigureOut">
               <a:rPr lang="en-US" smtClean="0"/>
-              <a:t>4/6/2026</a:t>
+              <a:t>4/7/2026</a:t>
             </a:fld>
             <a:endParaRPr lang="en-US"/>
           </a:p>
@@ -2323,7 +2506,7 @@
           <a:p>
             <a:fld id="{54E435BD-4569-4C00-96FD-DE6EEAA430DA}" type="datetimeFigureOut">
               <a:rPr lang="en-US" smtClean="0"/>
-              <a:t>4/6/2026</a:t>
+              <a:t>4/7/2026</a:t>
             </a:fld>
             <a:endParaRPr lang="en-US"/>
           </a:p>
@@ -2441,7 +2624,7 @@
           <a:p>
             <a:fld id="{54E435BD-4569-4C00-96FD-DE6EEAA430DA}" type="datetimeFigureOut">
               <a:rPr lang="en-US" smtClean="0"/>
-              <a:t>4/6/2026</a:t>
+              <a:t>4/7/2026</a:t>
             </a:fld>
             <a:endParaRPr lang="en-US"/>
           </a:p>
@@ -2536,7 +2719,7 @@
           <a:p>
             <a:fld id="{54E435BD-4569-4C00-96FD-DE6EEAA430DA}" type="datetimeFigureOut">
               <a:rPr lang="en-US" smtClean="0"/>
-              <a:t>4/6/2026</a:t>
+              <a:t>4/7/2026</a:t>
             </a:fld>
             <a:endParaRPr lang="en-US"/>
           </a:p>
@@ -2813,7 +2996,7 @@
           <a:p>
             <a:fld id="{54E435BD-4569-4C00-96FD-DE6EEAA430DA}" type="datetimeFigureOut">
               <a:rPr lang="en-US" smtClean="0"/>
-              <a:t>4/6/2026</a:t>
+              <a:t>4/7/2026</a:t>
             </a:fld>
             <a:endParaRPr lang="en-US"/>
           </a:p>
@@ -3070,7 +3253,7 @@
           <a:p>
             <a:fld id="{54E435BD-4569-4C00-96FD-DE6EEAA430DA}" type="datetimeFigureOut">
               <a:rPr lang="en-US" smtClean="0"/>
-              <a:t>4/6/2026</a:t>
+              <a:t>4/7/2026</a:t>
             </a:fld>
             <a:endParaRPr lang="en-US"/>
           </a:p>
@@ -3283,7 +3466,7 @@
           <a:p>
             <a:fld id="{54E435BD-4569-4C00-96FD-DE6EEAA430DA}" type="datetimeFigureOut">
               <a:rPr lang="en-US" smtClean="0"/>
-              <a:t>4/6/2026</a:t>
+              <a:t>4/7/2026</a:t>
             </a:fld>
             <a:endParaRPr lang="en-US"/>
           </a:p>
@@ -21780,42 +21963,6 @@
           </a:p>
         </p:txBody>
       </p:sp>
-      <p:pic>
-        <p:nvPicPr>
-          <p:cNvPr id="20" name="Graphic 19" descr="Group of men with solid fill">
-            <a:extLst>
-              <a:ext uri="{FF2B5EF4-FFF2-40B4-BE49-F238E27FC236}">
-                <a16:creationId xmlns:a16="http://schemas.microsoft.com/office/drawing/2014/main" id="{63E7276F-F01B-934A-CFDD-FB6D5F2EC7FE}"/>
-              </a:ext>
-            </a:extLst>
-          </p:cNvPr>
-          <p:cNvPicPr>
-            <a:picLocks noChangeAspect="1"/>
-          </p:cNvPicPr>
-          <p:nvPr/>
-        </p:nvPicPr>
-        <p:blipFill>
-          <a:blip>
-            <a:extLst>
-              <a:ext uri="{96DAC541-7B7A-43D3-8B79-37D633B846F1}">
-                <asvg:svgBlip xmlns:asvg="http://schemas.microsoft.com/office/drawing/2016/SVG/main" r:embed="rId2"/>
-              </a:ext>
-            </a:extLst>
-          </a:blip>
-          <a:stretch>
-            <a:fillRect/>
-          </a:stretch>
-        </p:blipFill>
-        <p:spPr>
-          <a:xfrm>
-            <a:off x="8069442" y="5507421"/>
-            <a:ext cx="914400" cy="914400"/>
-          </a:xfrm>
-          <a:prstGeom prst="rect">
-            <a:avLst/>
-          </a:prstGeom>
-        </p:spPr>
-      </p:pic>
       <p:sp>
         <p:nvSpPr>
           <p:cNvPr id="21" name="TextBox 20">
@@ -21963,7 +22110,7 @@
         </p:nvSpPr>
         <p:spPr>
           <a:xfrm>
-            <a:off x="8983842" y="4247190"/>
+            <a:off x="9025740" y="4253664"/>
             <a:ext cx="1474307" cy="338554"/>
           </a:xfrm>
           <a:prstGeom prst="rect">
@@ -22348,78 +22495,6 @@
           </a:p>
         </p:txBody>
       </p:sp>
-      <p:pic>
-        <p:nvPicPr>
-          <p:cNvPr id="27" name="Graphic 26" descr="Group of men with solid fill">
-            <a:extLst>
-              <a:ext uri="{FF2B5EF4-FFF2-40B4-BE49-F238E27FC236}">
-                <a16:creationId xmlns:a16="http://schemas.microsoft.com/office/drawing/2014/main" id="{2D97DDCB-7229-9321-0F73-E66F51B159CC}"/>
-              </a:ext>
-            </a:extLst>
-          </p:cNvPr>
-          <p:cNvPicPr>
-            <a:picLocks noChangeAspect="1"/>
-          </p:cNvPicPr>
-          <p:nvPr/>
-        </p:nvPicPr>
-        <p:blipFill>
-          <a:blip>
-            <a:extLst>
-              <a:ext uri="{96DAC541-7B7A-43D3-8B79-37D633B846F1}">
-                <asvg:svgBlip xmlns:asvg="http://schemas.microsoft.com/office/drawing/2016/SVG/main" r:embed="rId2"/>
-              </a:ext>
-            </a:extLst>
-          </a:blip>
-          <a:stretch>
-            <a:fillRect/>
-          </a:stretch>
-        </p:blipFill>
-        <p:spPr>
-          <a:xfrm>
-            <a:off x="8069442" y="3239342"/>
-            <a:ext cx="914400" cy="914400"/>
-          </a:xfrm>
-          <a:prstGeom prst="rect">
-            <a:avLst/>
-          </a:prstGeom>
-        </p:spPr>
-      </p:pic>
-      <p:pic>
-        <p:nvPicPr>
-          <p:cNvPr id="28" name="Graphic 27" descr="Group of men with solid fill">
-            <a:extLst>
-              <a:ext uri="{FF2B5EF4-FFF2-40B4-BE49-F238E27FC236}">
-                <a16:creationId xmlns:a16="http://schemas.microsoft.com/office/drawing/2014/main" id="{D84EF3F0-23DB-F3D5-FE38-1150762ADF3E}"/>
-              </a:ext>
-            </a:extLst>
-          </p:cNvPr>
-          <p:cNvPicPr>
-            <a:picLocks noChangeAspect="1"/>
-          </p:cNvPicPr>
-          <p:nvPr/>
-        </p:nvPicPr>
-        <p:blipFill>
-          <a:blip>
-            <a:extLst>
-              <a:ext uri="{96DAC541-7B7A-43D3-8B79-37D633B846F1}">
-                <asvg:svgBlip xmlns:asvg="http://schemas.microsoft.com/office/drawing/2016/SVG/main" r:embed="rId2"/>
-              </a:ext>
-            </a:extLst>
-          </a:blip>
-          <a:stretch>
-            <a:fillRect/>
-          </a:stretch>
-        </p:blipFill>
-        <p:spPr>
-          <a:xfrm>
-            <a:off x="8069442" y="4097609"/>
-            <a:ext cx="914400" cy="914400"/>
-          </a:xfrm>
-          <a:prstGeom prst="rect">
-            <a:avLst/>
-          </a:prstGeom>
-        </p:spPr>
-      </p:pic>
       <p:sp>
         <p:nvSpPr>
           <p:cNvPr id="29" name="TextBox 28">
@@ -23567,6 +23642,1032 @@
               </a:rPr>
               <a:t>Bottleneck</a:t>
             </a:r>
+          </a:p>
+        </p:txBody>
+      </p:sp>
+      <p:sp>
+        <p:nvSpPr>
+          <p:cNvPr id="18" name="Oval 17">
+            <a:extLst>
+              <a:ext uri="{FF2B5EF4-FFF2-40B4-BE49-F238E27FC236}">
+                <a16:creationId xmlns:a16="http://schemas.microsoft.com/office/drawing/2014/main" id="{E693494A-1F6E-3828-5FF9-CDAB056D0BCE}"/>
+              </a:ext>
+            </a:extLst>
+          </p:cNvPr>
+          <p:cNvSpPr/>
+          <p:nvPr/>
+        </p:nvSpPr>
+        <p:spPr>
+          <a:xfrm>
+            <a:off x="8072848" y="3330879"/>
+            <a:ext cx="182880" cy="182880"/>
+          </a:xfrm>
+          <a:prstGeom prst="ellipse">
+            <a:avLst/>
+          </a:prstGeom>
+          <a:solidFill>
+            <a:schemeClr val="tx1">
+              <a:lumMod val="50000"/>
+              <a:lumOff val="50000"/>
+            </a:schemeClr>
+          </a:solidFill>
+          <a:ln>
+            <a:solidFill>
+              <a:schemeClr val="tx1"/>
+            </a:solidFill>
+          </a:ln>
+        </p:spPr>
+        <p:style>
+          <a:lnRef idx="2">
+            <a:schemeClr val="accent1">
+              <a:shade val="15000"/>
+            </a:schemeClr>
+          </a:lnRef>
+          <a:fillRef idx="1">
+            <a:schemeClr val="accent1"/>
+          </a:fillRef>
+          <a:effectRef idx="0">
+            <a:schemeClr val="accent1"/>
+          </a:effectRef>
+          <a:fontRef idx="minor">
+            <a:schemeClr val="lt1"/>
+          </a:fontRef>
+        </p:style>
+        <p:txBody>
+          <a:bodyPr rtlCol="0" anchor="ctr"/>
+          <a:lstStyle/>
+          <a:p>
+            <a:pPr algn="ctr"/>
+            <a:endParaRPr lang="en-US"/>
+          </a:p>
+        </p:txBody>
+      </p:sp>
+      <p:sp>
+        <p:nvSpPr>
+          <p:cNvPr id="19" name="Rectangle: Top Corners Snipped 18">
+            <a:extLst>
+              <a:ext uri="{FF2B5EF4-FFF2-40B4-BE49-F238E27FC236}">
+                <a16:creationId xmlns:a16="http://schemas.microsoft.com/office/drawing/2014/main" id="{C1E6029E-39DA-FD90-8B4A-32E98571088F}"/>
+              </a:ext>
+            </a:extLst>
+          </p:cNvPr>
+          <p:cNvSpPr/>
+          <p:nvPr/>
+        </p:nvSpPr>
+        <p:spPr>
+          <a:xfrm>
+            <a:off x="7987125" y="3548262"/>
+            <a:ext cx="365760" cy="365760"/>
+          </a:xfrm>
+          <a:prstGeom prst="snip2SameRect">
+            <a:avLst/>
+          </a:prstGeom>
+          <a:solidFill>
+            <a:schemeClr val="tx1">
+              <a:lumMod val="50000"/>
+              <a:lumOff val="50000"/>
+            </a:schemeClr>
+          </a:solidFill>
+          <a:ln>
+            <a:solidFill>
+              <a:schemeClr val="tx1"/>
+            </a:solidFill>
+          </a:ln>
+        </p:spPr>
+        <p:style>
+          <a:lnRef idx="2">
+            <a:schemeClr val="accent1">
+              <a:shade val="15000"/>
+            </a:schemeClr>
+          </a:lnRef>
+          <a:fillRef idx="1">
+            <a:schemeClr val="accent1"/>
+          </a:fillRef>
+          <a:effectRef idx="0">
+            <a:schemeClr val="accent1"/>
+          </a:effectRef>
+          <a:fontRef idx="minor">
+            <a:schemeClr val="lt1"/>
+          </a:fontRef>
+        </p:style>
+        <p:txBody>
+          <a:bodyPr rtlCol="0" anchor="ctr"/>
+          <a:lstStyle/>
+          <a:p>
+            <a:pPr algn="ctr"/>
+            <a:endParaRPr lang="en-US"/>
+          </a:p>
+        </p:txBody>
+      </p:sp>
+      <p:sp>
+        <p:nvSpPr>
+          <p:cNvPr id="22" name="Oval 21">
+            <a:extLst>
+              <a:ext uri="{FF2B5EF4-FFF2-40B4-BE49-F238E27FC236}">
+                <a16:creationId xmlns:a16="http://schemas.microsoft.com/office/drawing/2014/main" id="{1CE5FA1F-948A-538B-E275-31FE8E471619}"/>
+              </a:ext>
+            </a:extLst>
+          </p:cNvPr>
+          <p:cNvSpPr/>
+          <p:nvPr/>
+        </p:nvSpPr>
+        <p:spPr>
+          <a:xfrm>
+            <a:off x="8313803" y="3362907"/>
+            <a:ext cx="182880" cy="182880"/>
+          </a:xfrm>
+          <a:prstGeom prst="ellipse">
+            <a:avLst/>
+          </a:prstGeom>
+          <a:solidFill>
+            <a:schemeClr val="tx1">
+              <a:lumMod val="50000"/>
+              <a:lumOff val="50000"/>
+            </a:schemeClr>
+          </a:solidFill>
+          <a:ln>
+            <a:solidFill>
+              <a:schemeClr val="tx1"/>
+            </a:solidFill>
+          </a:ln>
+        </p:spPr>
+        <p:style>
+          <a:lnRef idx="2">
+            <a:schemeClr val="accent1">
+              <a:shade val="15000"/>
+            </a:schemeClr>
+          </a:lnRef>
+          <a:fillRef idx="1">
+            <a:schemeClr val="accent1"/>
+          </a:fillRef>
+          <a:effectRef idx="0">
+            <a:schemeClr val="accent1"/>
+          </a:effectRef>
+          <a:fontRef idx="minor">
+            <a:schemeClr val="lt1"/>
+          </a:fontRef>
+        </p:style>
+        <p:txBody>
+          <a:bodyPr rtlCol="0" anchor="ctr"/>
+          <a:lstStyle/>
+          <a:p>
+            <a:pPr algn="ctr"/>
+            <a:endParaRPr lang="en-US"/>
+          </a:p>
+        </p:txBody>
+      </p:sp>
+      <p:sp>
+        <p:nvSpPr>
+          <p:cNvPr id="23" name="Rectangle: Top Corners Snipped 22">
+            <a:extLst>
+              <a:ext uri="{FF2B5EF4-FFF2-40B4-BE49-F238E27FC236}">
+                <a16:creationId xmlns:a16="http://schemas.microsoft.com/office/drawing/2014/main" id="{FE72382F-F6F9-66C7-4183-4E055D409F7D}"/>
+              </a:ext>
+            </a:extLst>
+          </p:cNvPr>
+          <p:cNvSpPr/>
+          <p:nvPr/>
+        </p:nvSpPr>
+        <p:spPr>
+          <a:xfrm>
+            <a:off x="8228080" y="3580290"/>
+            <a:ext cx="365760" cy="365760"/>
+          </a:xfrm>
+          <a:prstGeom prst="snip2SameRect">
+            <a:avLst/>
+          </a:prstGeom>
+          <a:solidFill>
+            <a:schemeClr val="tx1">
+              <a:lumMod val="50000"/>
+              <a:lumOff val="50000"/>
+            </a:schemeClr>
+          </a:solidFill>
+          <a:ln>
+            <a:solidFill>
+              <a:schemeClr val="tx1"/>
+            </a:solidFill>
+          </a:ln>
+        </p:spPr>
+        <p:style>
+          <a:lnRef idx="2">
+            <a:schemeClr val="accent1">
+              <a:shade val="15000"/>
+            </a:schemeClr>
+          </a:lnRef>
+          <a:fillRef idx="1">
+            <a:schemeClr val="accent1"/>
+          </a:fillRef>
+          <a:effectRef idx="0">
+            <a:schemeClr val="accent1"/>
+          </a:effectRef>
+          <a:fontRef idx="minor">
+            <a:schemeClr val="lt1"/>
+          </a:fontRef>
+        </p:style>
+        <p:txBody>
+          <a:bodyPr rtlCol="0" anchor="ctr"/>
+          <a:lstStyle/>
+          <a:p>
+            <a:pPr algn="ctr"/>
+            <a:endParaRPr lang="en-US"/>
+          </a:p>
+        </p:txBody>
+      </p:sp>
+      <p:sp>
+        <p:nvSpPr>
+          <p:cNvPr id="38" name="Oval 37">
+            <a:extLst>
+              <a:ext uri="{FF2B5EF4-FFF2-40B4-BE49-F238E27FC236}">
+                <a16:creationId xmlns:a16="http://schemas.microsoft.com/office/drawing/2014/main" id="{FC0509F7-8873-EC72-329F-1640ED6E36B3}"/>
+              </a:ext>
+            </a:extLst>
+          </p:cNvPr>
+          <p:cNvSpPr/>
+          <p:nvPr/>
+        </p:nvSpPr>
+        <p:spPr>
+          <a:xfrm>
+            <a:off x="8548725" y="3398838"/>
+            <a:ext cx="182880" cy="182880"/>
+          </a:xfrm>
+          <a:prstGeom prst="ellipse">
+            <a:avLst/>
+          </a:prstGeom>
+          <a:solidFill>
+            <a:schemeClr val="tx1">
+              <a:lumMod val="50000"/>
+              <a:lumOff val="50000"/>
+            </a:schemeClr>
+          </a:solidFill>
+          <a:ln>
+            <a:solidFill>
+              <a:schemeClr val="tx1"/>
+            </a:solidFill>
+          </a:ln>
+        </p:spPr>
+        <p:style>
+          <a:lnRef idx="2">
+            <a:schemeClr val="accent1">
+              <a:shade val="15000"/>
+            </a:schemeClr>
+          </a:lnRef>
+          <a:fillRef idx="1">
+            <a:schemeClr val="accent1"/>
+          </a:fillRef>
+          <a:effectRef idx="0">
+            <a:schemeClr val="accent1"/>
+          </a:effectRef>
+          <a:fontRef idx="minor">
+            <a:schemeClr val="lt1"/>
+          </a:fontRef>
+        </p:style>
+        <p:txBody>
+          <a:bodyPr rtlCol="0" anchor="ctr"/>
+          <a:lstStyle/>
+          <a:p>
+            <a:pPr algn="ctr"/>
+            <a:endParaRPr lang="en-US"/>
+          </a:p>
+        </p:txBody>
+      </p:sp>
+      <p:sp>
+        <p:nvSpPr>
+          <p:cNvPr id="39" name="Rectangle: Top Corners Snipped 38">
+            <a:extLst>
+              <a:ext uri="{FF2B5EF4-FFF2-40B4-BE49-F238E27FC236}">
+                <a16:creationId xmlns:a16="http://schemas.microsoft.com/office/drawing/2014/main" id="{5680E036-C301-C623-414E-BC2D5E341D9A}"/>
+              </a:ext>
+            </a:extLst>
+          </p:cNvPr>
+          <p:cNvSpPr/>
+          <p:nvPr/>
+        </p:nvSpPr>
+        <p:spPr>
+          <a:xfrm>
+            <a:off x="8463002" y="3616221"/>
+            <a:ext cx="365760" cy="365760"/>
+          </a:xfrm>
+          <a:prstGeom prst="snip2SameRect">
+            <a:avLst/>
+          </a:prstGeom>
+          <a:solidFill>
+            <a:schemeClr val="tx1">
+              <a:lumMod val="50000"/>
+              <a:lumOff val="50000"/>
+            </a:schemeClr>
+          </a:solidFill>
+          <a:ln>
+            <a:solidFill>
+              <a:schemeClr val="tx1"/>
+            </a:solidFill>
+          </a:ln>
+        </p:spPr>
+        <p:style>
+          <a:lnRef idx="2">
+            <a:schemeClr val="accent1">
+              <a:shade val="15000"/>
+            </a:schemeClr>
+          </a:lnRef>
+          <a:fillRef idx="1">
+            <a:schemeClr val="accent1"/>
+          </a:fillRef>
+          <a:effectRef idx="0">
+            <a:schemeClr val="accent1"/>
+          </a:effectRef>
+          <a:fontRef idx="minor">
+            <a:schemeClr val="lt1"/>
+          </a:fontRef>
+        </p:style>
+        <p:txBody>
+          <a:bodyPr rtlCol="0" anchor="ctr"/>
+          <a:lstStyle/>
+          <a:p>
+            <a:pPr algn="ctr"/>
+            <a:endParaRPr lang="en-US"/>
+          </a:p>
+        </p:txBody>
+      </p:sp>
+      <p:sp>
+        <p:nvSpPr>
+          <p:cNvPr id="40" name="Oval 39">
+            <a:extLst>
+              <a:ext uri="{FF2B5EF4-FFF2-40B4-BE49-F238E27FC236}">
+                <a16:creationId xmlns:a16="http://schemas.microsoft.com/office/drawing/2014/main" id="{7688E15F-1386-C937-0163-2EC5DDC4ACE1}"/>
+              </a:ext>
+            </a:extLst>
+          </p:cNvPr>
+          <p:cNvSpPr/>
+          <p:nvPr/>
+        </p:nvSpPr>
+        <p:spPr>
+          <a:xfrm>
+            <a:off x="8079670" y="4124127"/>
+            <a:ext cx="182880" cy="182880"/>
+          </a:xfrm>
+          <a:prstGeom prst="ellipse">
+            <a:avLst/>
+          </a:prstGeom>
+          <a:solidFill>
+            <a:schemeClr val="tx1">
+              <a:lumMod val="50000"/>
+              <a:lumOff val="50000"/>
+            </a:schemeClr>
+          </a:solidFill>
+          <a:ln>
+            <a:solidFill>
+              <a:schemeClr val="tx1"/>
+            </a:solidFill>
+          </a:ln>
+        </p:spPr>
+        <p:style>
+          <a:lnRef idx="2">
+            <a:schemeClr val="accent1">
+              <a:shade val="15000"/>
+            </a:schemeClr>
+          </a:lnRef>
+          <a:fillRef idx="1">
+            <a:schemeClr val="accent1"/>
+          </a:fillRef>
+          <a:effectRef idx="0">
+            <a:schemeClr val="accent1"/>
+          </a:effectRef>
+          <a:fontRef idx="minor">
+            <a:schemeClr val="lt1"/>
+          </a:fontRef>
+        </p:style>
+        <p:txBody>
+          <a:bodyPr rtlCol="0" anchor="ctr"/>
+          <a:lstStyle/>
+          <a:p>
+            <a:pPr algn="ctr"/>
+            <a:endParaRPr lang="en-US"/>
+          </a:p>
+        </p:txBody>
+      </p:sp>
+      <p:sp>
+        <p:nvSpPr>
+          <p:cNvPr id="41" name="Rectangle: Top Corners Snipped 40">
+            <a:extLst>
+              <a:ext uri="{FF2B5EF4-FFF2-40B4-BE49-F238E27FC236}">
+                <a16:creationId xmlns:a16="http://schemas.microsoft.com/office/drawing/2014/main" id="{B641507C-62A6-FF4F-D8BC-CDF153439BD5}"/>
+              </a:ext>
+            </a:extLst>
+          </p:cNvPr>
+          <p:cNvSpPr/>
+          <p:nvPr/>
+        </p:nvSpPr>
+        <p:spPr>
+          <a:xfrm>
+            <a:off x="7993947" y="4341510"/>
+            <a:ext cx="365760" cy="365760"/>
+          </a:xfrm>
+          <a:prstGeom prst="snip2SameRect">
+            <a:avLst/>
+          </a:prstGeom>
+          <a:solidFill>
+            <a:schemeClr val="tx1">
+              <a:lumMod val="50000"/>
+              <a:lumOff val="50000"/>
+            </a:schemeClr>
+          </a:solidFill>
+          <a:ln>
+            <a:solidFill>
+              <a:schemeClr val="tx1"/>
+            </a:solidFill>
+          </a:ln>
+        </p:spPr>
+        <p:style>
+          <a:lnRef idx="2">
+            <a:schemeClr val="accent1">
+              <a:shade val="15000"/>
+            </a:schemeClr>
+          </a:lnRef>
+          <a:fillRef idx="1">
+            <a:schemeClr val="accent1"/>
+          </a:fillRef>
+          <a:effectRef idx="0">
+            <a:schemeClr val="accent1"/>
+          </a:effectRef>
+          <a:fontRef idx="minor">
+            <a:schemeClr val="lt1"/>
+          </a:fontRef>
+        </p:style>
+        <p:txBody>
+          <a:bodyPr rtlCol="0" anchor="ctr"/>
+          <a:lstStyle/>
+          <a:p>
+            <a:pPr algn="ctr"/>
+            <a:endParaRPr lang="en-US"/>
+          </a:p>
+        </p:txBody>
+      </p:sp>
+      <p:sp>
+        <p:nvSpPr>
+          <p:cNvPr id="42" name="Oval 41">
+            <a:extLst>
+              <a:ext uri="{FF2B5EF4-FFF2-40B4-BE49-F238E27FC236}">
+                <a16:creationId xmlns:a16="http://schemas.microsoft.com/office/drawing/2014/main" id="{DE6853C4-E8CA-CF2A-8099-234DC2B4E289}"/>
+              </a:ext>
+            </a:extLst>
+          </p:cNvPr>
+          <p:cNvSpPr/>
+          <p:nvPr/>
+        </p:nvSpPr>
+        <p:spPr>
+          <a:xfrm>
+            <a:off x="8320625" y="4156155"/>
+            <a:ext cx="182880" cy="182880"/>
+          </a:xfrm>
+          <a:prstGeom prst="ellipse">
+            <a:avLst/>
+          </a:prstGeom>
+          <a:solidFill>
+            <a:schemeClr val="tx1">
+              <a:lumMod val="50000"/>
+              <a:lumOff val="50000"/>
+            </a:schemeClr>
+          </a:solidFill>
+          <a:ln>
+            <a:solidFill>
+              <a:schemeClr val="tx1"/>
+            </a:solidFill>
+          </a:ln>
+        </p:spPr>
+        <p:style>
+          <a:lnRef idx="2">
+            <a:schemeClr val="accent1">
+              <a:shade val="15000"/>
+            </a:schemeClr>
+          </a:lnRef>
+          <a:fillRef idx="1">
+            <a:schemeClr val="accent1"/>
+          </a:fillRef>
+          <a:effectRef idx="0">
+            <a:schemeClr val="accent1"/>
+          </a:effectRef>
+          <a:fontRef idx="minor">
+            <a:schemeClr val="lt1"/>
+          </a:fontRef>
+        </p:style>
+        <p:txBody>
+          <a:bodyPr rtlCol="0" anchor="ctr"/>
+          <a:lstStyle/>
+          <a:p>
+            <a:pPr algn="ctr"/>
+            <a:endParaRPr lang="en-US"/>
+          </a:p>
+        </p:txBody>
+      </p:sp>
+      <p:sp>
+        <p:nvSpPr>
+          <p:cNvPr id="43" name="Rectangle: Top Corners Snipped 42">
+            <a:extLst>
+              <a:ext uri="{FF2B5EF4-FFF2-40B4-BE49-F238E27FC236}">
+                <a16:creationId xmlns:a16="http://schemas.microsoft.com/office/drawing/2014/main" id="{305571C5-AE62-5FEB-178F-92AF31427263}"/>
+              </a:ext>
+            </a:extLst>
+          </p:cNvPr>
+          <p:cNvSpPr/>
+          <p:nvPr/>
+        </p:nvSpPr>
+        <p:spPr>
+          <a:xfrm>
+            <a:off x="8234902" y="4373538"/>
+            <a:ext cx="365760" cy="365760"/>
+          </a:xfrm>
+          <a:prstGeom prst="snip2SameRect">
+            <a:avLst/>
+          </a:prstGeom>
+          <a:solidFill>
+            <a:schemeClr val="tx1">
+              <a:lumMod val="50000"/>
+              <a:lumOff val="50000"/>
+            </a:schemeClr>
+          </a:solidFill>
+          <a:ln>
+            <a:solidFill>
+              <a:schemeClr val="tx1"/>
+            </a:solidFill>
+          </a:ln>
+        </p:spPr>
+        <p:style>
+          <a:lnRef idx="2">
+            <a:schemeClr val="accent1">
+              <a:shade val="15000"/>
+            </a:schemeClr>
+          </a:lnRef>
+          <a:fillRef idx="1">
+            <a:schemeClr val="accent1"/>
+          </a:fillRef>
+          <a:effectRef idx="0">
+            <a:schemeClr val="accent1"/>
+          </a:effectRef>
+          <a:fontRef idx="minor">
+            <a:schemeClr val="lt1"/>
+          </a:fontRef>
+        </p:style>
+        <p:txBody>
+          <a:bodyPr rtlCol="0" anchor="ctr"/>
+          <a:lstStyle/>
+          <a:p>
+            <a:pPr algn="ctr"/>
+            <a:endParaRPr lang="en-US"/>
+          </a:p>
+        </p:txBody>
+      </p:sp>
+      <p:sp>
+        <p:nvSpPr>
+          <p:cNvPr id="44" name="Oval 43">
+            <a:extLst>
+              <a:ext uri="{FF2B5EF4-FFF2-40B4-BE49-F238E27FC236}">
+                <a16:creationId xmlns:a16="http://schemas.microsoft.com/office/drawing/2014/main" id="{A5BD21AD-9160-37C5-E402-1912AF878518}"/>
+              </a:ext>
+            </a:extLst>
+          </p:cNvPr>
+          <p:cNvSpPr/>
+          <p:nvPr/>
+        </p:nvSpPr>
+        <p:spPr>
+          <a:xfrm>
+            <a:off x="8555547" y="4192086"/>
+            <a:ext cx="182880" cy="182880"/>
+          </a:xfrm>
+          <a:prstGeom prst="ellipse">
+            <a:avLst/>
+          </a:prstGeom>
+          <a:solidFill>
+            <a:schemeClr val="tx1">
+              <a:lumMod val="50000"/>
+              <a:lumOff val="50000"/>
+            </a:schemeClr>
+          </a:solidFill>
+          <a:ln>
+            <a:solidFill>
+              <a:schemeClr val="tx1"/>
+            </a:solidFill>
+          </a:ln>
+        </p:spPr>
+        <p:style>
+          <a:lnRef idx="2">
+            <a:schemeClr val="accent1">
+              <a:shade val="15000"/>
+            </a:schemeClr>
+          </a:lnRef>
+          <a:fillRef idx="1">
+            <a:schemeClr val="accent1"/>
+          </a:fillRef>
+          <a:effectRef idx="0">
+            <a:schemeClr val="accent1"/>
+          </a:effectRef>
+          <a:fontRef idx="minor">
+            <a:schemeClr val="lt1"/>
+          </a:fontRef>
+        </p:style>
+        <p:txBody>
+          <a:bodyPr rtlCol="0" anchor="ctr"/>
+          <a:lstStyle/>
+          <a:p>
+            <a:pPr algn="ctr"/>
+            <a:endParaRPr lang="en-US"/>
+          </a:p>
+        </p:txBody>
+      </p:sp>
+      <p:sp>
+        <p:nvSpPr>
+          <p:cNvPr id="45" name="Rectangle: Top Corners Snipped 44">
+            <a:extLst>
+              <a:ext uri="{FF2B5EF4-FFF2-40B4-BE49-F238E27FC236}">
+                <a16:creationId xmlns:a16="http://schemas.microsoft.com/office/drawing/2014/main" id="{871380D0-3166-4CAB-8D48-B8B10A1216F4}"/>
+              </a:ext>
+            </a:extLst>
+          </p:cNvPr>
+          <p:cNvSpPr/>
+          <p:nvPr/>
+        </p:nvSpPr>
+        <p:spPr>
+          <a:xfrm>
+            <a:off x="8469824" y="4409469"/>
+            <a:ext cx="365760" cy="365760"/>
+          </a:xfrm>
+          <a:prstGeom prst="snip2SameRect">
+            <a:avLst/>
+          </a:prstGeom>
+          <a:solidFill>
+            <a:schemeClr val="tx1">
+              <a:lumMod val="50000"/>
+              <a:lumOff val="50000"/>
+            </a:schemeClr>
+          </a:solidFill>
+          <a:ln>
+            <a:solidFill>
+              <a:schemeClr val="tx1"/>
+            </a:solidFill>
+          </a:ln>
+        </p:spPr>
+        <p:style>
+          <a:lnRef idx="2">
+            <a:schemeClr val="accent1">
+              <a:shade val="15000"/>
+            </a:schemeClr>
+          </a:lnRef>
+          <a:fillRef idx="1">
+            <a:schemeClr val="accent1"/>
+          </a:fillRef>
+          <a:effectRef idx="0">
+            <a:schemeClr val="accent1"/>
+          </a:effectRef>
+          <a:fontRef idx="minor">
+            <a:schemeClr val="lt1"/>
+          </a:fontRef>
+        </p:style>
+        <p:txBody>
+          <a:bodyPr rtlCol="0" anchor="ctr"/>
+          <a:lstStyle/>
+          <a:p>
+            <a:pPr algn="ctr"/>
+            <a:endParaRPr lang="en-US"/>
+          </a:p>
+        </p:txBody>
+      </p:sp>
+      <p:sp>
+        <p:nvSpPr>
+          <p:cNvPr id="46" name="Oval 45">
+            <a:extLst>
+              <a:ext uri="{FF2B5EF4-FFF2-40B4-BE49-F238E27FC236}">
+                <a16:creationId xmlns:a16="http://schemas.microsoft.com/office/drawing/2014/main" id="{669993EF-587D-E4B8-4DCB-745E77C10007}"/>
+              </a:ext>
+            </a:extLst>
+          </p:cNvPr>
+          <p:cNvSpPr/>
+          <p:nvPr/>
+        </p:nvSpPr>
+        <p:spPr>
+          <a:xfrm>
+            <a:off x="8112475" y="5531389"/>
+            <a:ext cx="182880" cy="182880"/>
+          </a:xfrm>
+          <a:prstGeom prst="ellipse">
+            <a:avLst/>
+          </a:prstGeom>
+          <a:solidFill>
+            <a:schemeClr val="tx1">
+              <a:lumMod val="50000"/>
+              <a:lumOff val="50000"/>
+            </a:schemeClr>
+          </a:solidFill>
+          <a:ln>
+            <a:solidFill>
+              <a:schemeClr val="tx1"/>
+            </a:solidFill>
+          </a:ln>
+        </p:spPr>
+        <p:style>
+          <a:lnRef idx="2">
+            <a:schemeClr val="accent1">
+              <a:shade val="15000"/>
+            </a:schemeClr>
+          </a:lnRef>
+          <a:fillRef idx="1">
+            <a:schemeClr val="accent1"/>
+          </a:fillRef>
+          <a:effectRef idx="0">
+            <a:schemeClr val="accent1"/>
+          </a:effectRef>
+          <a:fontRef idx="minor">
+            <a:schemeClr val="lt1"/>
+          </a:fontRef>
+        </p:style>
+        <p:txBody>
+          <a:bodyPr rtlCol="0" anchor="ctr"/>
+          <a:lstStyle/>
+          <a:p>
+            <a:pPr algn="ctr"/>
+            <a:endParaRPr lang="en-US"/>
+          </a:p>
+        </p:txBody>
+      </p:sp>
+      <p:sp>
+        <p:nvSpPr>
+          <p:cNvPr id="47" name="Rectangle: Top Corners Snipped 46">
+            <a:extLst>
+              <a:ext uri="{FF2B5EF4-FFF2-40B4-BE49-F238E27FC236}">
+                <a16:creationId xmlns:a16="http://schemas.microsoft.com/office/drawing/2014/main" id="{4315D537-113D-8E6A-1582-C204AA39D1FF}"/>
+              </a:ext>
+            </a:extLst>
+          </p:cNvPr>
+          <p:cNvSpPr/>
+          <p:nvPr/>
+        </p:nvSpPr>
+        <p:spPr>
+          <a:xfrm>
+            <a:off x="8026752" y="5748772"/>
+            <a:ext cx="365760" cy="365760"/>
+          </a:xfrm>
+          <a:prstGeom prst="snip2SameRect">
+            <a:avLst/>
+          </a:prstGeom>
+          <a:solidFill>
+            <a:schemeClr val="tx1">
+              <a:lumMod val="50000"/>
+              <a:lumOff val="50000"/>
+            </a:schemeClr>
+          </a:solidFill>
+          <a:ln>
+            <a:solidFill>
+              <a:schemeClr val="tx1"/>
+            </a:solidFill>
+          </a:ln>
+        </p:spPr>
+        <p:style>
+          <a:lnRef idx="2">
+            <a:schemeClr val="accent1">
+              <a:shade val="15000"/>
+            </a:schemeClr>
+          </a:lnRef>
+          <a:fillRef idx="1">
+            <a:schemeClr val="accent1"/>
+          </a:fillRef>
+          <a:effectRef idx="0">
+            <a:schemeClr val="accent1"/>
+          </a:effectRef>
+          <a:fontRef idx="minor">
+            <a:schemeClr val="lt1"/>
+          </a:fontRef>
+        </p:style>
+        <p:txBody>
+          <a:bodyPr rtlCol="0" anchor="ctr"/>
+          <a:lstStyle/>
+          <a:p>
+            <a:pPr algn="ctr"/>
+            <a:endParaRPr lang="en-US"/>
+          </a:p>
+        </p:txBody>
+      </p:sp>
+      <p:sp>
+        <p:nvSpPr>
+          <p:cNvPr id="48" name="Oval 47">
+            <a:extLst>
+              <a:ext uri="{FF2B5EF4-FFF2-40B4-BE49-F238E27FC236}">
+                <a16:creationId xmlns:a16="http://schemas.microsoft.com/office/drawing/2014/main" id="{963E9682-998A-6596-A3B2-CF7BDC9DF45C}"/>
+              </a:ext>
+            </a:extLst>
+          </p:cNvPr>
+          <p:cNvSpPr/>
+          <p:nvPr/>
+        </p:nvSpPr>
+        <p:spPr>
+          <a:xfrm>
+            <a:off x="8353430" y="5563417"/>
+            <a:ext cx="182880" cy="182880"/>
+          </a:xfrm>
+          <a:prstGeom prst="ellipse">
+            <a:avLst/>
+          </a:prstGeom>
+          <a:solidFill>
+            <a:schemeClr val="tx1">
+              <a:lumMod val="50000"/>
+              <a:lumOff val="50000"/>
+            </a:schemeClr>
+          </a:solidFill>
+          <a:ln>
+            <a:solidFill>
+              <a:schemeClr val="tx1"/>
+            </a:solidFill>
+          </a:ln>
+        </p:spPr>
+        <p:style>
+          <a:lnRef idx="2">
+            <a:schemeClr val="accent1">
+              <a:shade val="15000"/>
+            </a:schemeClr>
+          </a:lnRef>
+          <a:fillRef idx="1">
+            <a:schemeClr val="accent1"/>
+          </a:fillRef>
+          <a:effectRef idx="0">
+            <a:schemeClr val="accent1"/>
+          </a:effectRef>
+          <a:fontRef idx="minor">
+            <a:schemeClr val="lt1"/>
+          </a:fontRef>
+        </p:style>
+        <p:txBody>
+          <a:bodyPr rtlCol="0" anchor="ctr"/>
+          <a:lstStyle/>
+          <a:p>
+            <a:pPr algn="ctr"/>
+            <a:endParaRPr lang="en-US"/>
+          </a:p>
+        </p:txBody>
+      </p:sp>
+      <p:sp>
+        <p:nvSpPr>
+          <p:cNvPr id="49" name="Rectangle: Top Corners Snipped 48">
+            <a:extLst>
+              <a:ext uri="{FF2B5EF4-FFF2-40B4-BE49-F238E27FC236}">
+                <a16:creationId xmlns:a16="http://schemas.microsoft.com/office/drawing/2014/main" id="{BB2FCBC0-DF2A-1EB3-1EB7-9D014B509F6B}"/>
+              </a:ext>
+            </a:extLst>
+          </p:cNvPr>
+          <p:cNvSpPr/>
+          <p:nvPr/>
+        </p:nvSpPr>
+        <p:spPr>
+          <a:xfrm>
+            <a:off x="8267707" y="5780800"/>
+            <a:ext cx="365760" cy="365760"/>
+          </a:xfrm>
+          <a:prstGeom prst="snip2SameRect">
+            <a:avLst/>
+          </a:prstGeom>
+          <a:solidFill>
+            <a:schemeClr val="tx1">
+              <a:lumMod val="50000"/>
+              <a:lumOff val="50000"/>
+            </a:schemeClr>
+          </a:solidFill>
+          <a:ln>
+            <a:solidFill>
+              <a:schemeClr val="tx1"/>
+            </a:solidFill>
+          </a:ln>
+        </p:spPr>
+        <p:style>
+          <a:lnRef idx="2">
+            <a:schemeClr val="accent1">
+              <a:shade val="15000"/>
+            </a:schemeClr>
+          </a:lnRef>
+          <a:fillRef idx="1">
+            <a:schemeClr val="accent1"/>
+          </a:fillRef>
+          <a:effectRef idx="0">
+            <a:schemeClr val="accent1"/>
+          </a:effectRef>
+          <a:fontRef idx="minor">
+            <a:schemeClr val="lt1"/>
+          </a:fontRef>
+        </p:style>
+        <p:txBody>
+          <a:bodyPr rtlCol="0" anchor="ctr"/>
+          <a:lstStyle/>
+          <a:p>
+            <a:pPr algn="ctr"/>
+            <a:endParaRPr lang="en-US"/>
+          </a:p>
+        </p:txBody>
+      </p:sp>
+      <p:sp>
+        <p:nvSpPr>
+          <p:cNvPr id="50" name="Oval 49">
+            <a:extLst>
+              <a:ext uri="{FF2B5EF4-FFF2-40B4-BE49-F238E27FC236}">
+                <a16:creationId xmlns:a16="http://schemas.microsoft.com/office/drawing/2014/main" id="{380B9967-3D2A-6290-9C24-45B1B3248F5A}"/>
+              </a:ext>
+            </a:extLst>
+          </p:cNvPr>
+          <p:cNvSpPr/>
+          <p:nvPr/>
+        </p:nvSpPr>
+        <p:spPr>
+          <a:xfrm>
+            <a:off x="8588352" y="5599348"/>
+            <a:ext cx="182880" cy="182880"/>
+          </a:xfrm>
+          <a:prstGeom prst="ellipse">
+            <a:avLst/>
+          </a:prstGeom>
+          <a:solidFill>
+            <a:schemeClr val="tx1">
+              <a:lumMod val="50000"/>
+              <a:lumOff val="50000"/>
+            </a:schemeClr>
+          </a:solidFill>
+          <a:ln>
+            <a:solidFill>
+              <a:schemeClr val="tx1"/>
+            </a:solidFill>
+          </a:ln>
+        </p:spPr>
+        <p:style>
+          <a:lnRef idx="2">
+            <a:schemeClr val="accent1">
+              <a:shade val="15000"/>
+            </a:schemeClr>
+          </a:lnRef>
+          <a:fillRef idx="1">
+            <a:schemeClr val="accent1"/>
+          </a:fillRef>
+          <a:effectRef idx="0">
+            <a:schemeClr val="accent1"/>
+          </a:effectRef>
+          <a:fontRef idx="minor">
+            <a:schemeClr val="lt1"/>
+          </a:fontRef>
+        </p:style>
+        <p:txBody>
+          <a:bodyPr rtlCol="0" anchor="ctr"/>
+          <a:lstStyle/>
+          <a:p>
+            <a:pPr algn="ctr"/>
+            <a:endParaRPr lang="en-US"/>
+          </a:p>
+        </p:txBody>
+      </p:sp>
+      <p:sp>
+        <p:nvSpPr>
+          <p:cNvPr id="51" name="Rectangle: Top Corners Snipped 50">
+            <a:extLst>
+              <a:ext uri="{FF2B5EF4-FFF2-40B4-BE49-F238E27FC236}">
+                <a16:creationId xmlns:a16="http://schemas.microsoft.com/office/drawing/2014/main" id="{9BBB25C2-AD51-EF46-0526-6F8284826624}"/>
+              </a:ext>
+            </a:extLst>
+          </p:cNvPr>
+          <p:cNvSpPr/>
+          <p:nvPr/>
+        </p:nvSpPr>
+        <p:spPr>
+          <a:xfrm>
+            <a:off x="8502629" y="5816731"/>
+            <a:ext cx="365760" cy="365760"/>
+          </a:xfrm>
+          <a:prstGeom prst="snip2SameRect">
+            <a:avLst/>
+          </a:prstGeom>
+          <a:solidFill>
+            <a:schemeClr val="tx1">
+              <a:lumMod val="50000"/>
+              <a:lumOff val="50000"/>
+            </a:schemeClr>
+          </a:solidFill>
+          <a:ln>
+            <a:solidFill>
+              <a:schemeClr val="tx1"/>
+            </a:solidFill>
+          </a:ln>
+        </p:spPr>
+        <p:style>
+          <a:lnRef idx="2">
+            <a:schemeClr val="accent1">
+              <a:shade val="15000"/>
+            </a:schemeClr>
+          </a:lnRef>
+          <a:fillRef idx="1">
+            <a:schemeClr val="accent1"/>
+          </a:fillRef>
+          <a:effectRef idx="0">
+            <a:schemeClr val="accent1"/>
+          </a:effectRef>
+          <a:fontRef idx="minor">
+            <a:schemeClr val="lt1"/>
+          </a:fontRef>
+        </p:style>
+        <p:txBody>
+          <a:bodyPr rtlCol="0" anchor="ctr"/>
+          <a:lstStyle/>
+          <a:p>
+            <a:pPr algn="ctr"/>
+            <a:endParaRPr lang="en-US"/>
           </a:p>
         </p:txBody>
       </p:sp>

</xml_diff>